<commit_message>
docs: add agent guidance and retire unsupported fuzzing documentation
</commit_message>
<xml_diff>
--- a/docs/presentation/VulnHunterX-60min.pptx
+++ b/docs/presentation/VulnHunterX-60min.pptx
@@ -876,12 +876,12 @@
           </a:p>
           <a:p>
             <a:r>
-              <a:t>README summary table is stale). CodeQL custom = 64, Semgrep custom =</a:t>
-            </a:r>
-          </a:p>
-          <a:p>
-            <a:r>
-              <a:t>103, guided-question rule-sets ~= 366 across</a:t>
+              <a:t>README summary table is stale). CodeQL custom = 65, Semgrep custom =</a:t>
+            </a:r>
+          </a:p>
+          <a:p>
+            <a:r>
+              <a:t>108, guided-question rule-sets ~= 365 across</a:t>
             </a:r>
           </a:p>
           <a:p>
@@ -1866,12 +1866,7 @@
           </a:p>
           <a:p>
             <a:r>
-              <a:t>examples/pipeline_c.py runs c-ares (real-world) + dvcp. The --fuzz stretch runs a</a:t>
-            </a:r>
-          </a:p>
-          <a:p>
-            <a:r>
-              <a:t>sanitizer build + libFuzzer on c-ares (Linux/macOS only). Bring your TP/FP list to</a:t>
+              <a:t>examples/pipeline_c.py runs c-ares (real-world) + dvcp. Bring your TP/FP list to</a:t>
             </a:r>
           </a:p>
           <a:p>
@@ -2351,17 +2346,12 @@
           <a:lstStyle/>
           <a:p>
             <a:r>
-              <a:t>README "Pipeline Stages". prepare → analyze → verify → report are the core four;</a:t>
-            </a:r>
-          </a:p>
-          <a:p>
-            <a:r>
-              <a:t>`scan` runs them in one command. Fuzz stages only apply to C/C++ and only on</a:t>
-            </a:r>
-          </a:p>
-          <a:p>
-            <a:r>
-              <a:t>Linux/macOS (covered under Windows support).</a:t>
+              <a:t>README "Pipeline Stages". prepare → analyze → verify → report are the four</a:t>
+            </a:r>
+          </a:p>
+          <a:p>
+            <a:r>
+              <a:t>supported stages; `scan` runs them in one command.</a:t>
             </a:r>
           </a:p>
         </p:txBody>
@@ -6098,7 +6088,7 @@
                 </a:solidFill>
                 <a:latin typeface="Segoe UI"/>
               </a:rPr>
-              <a:t>64  </a:t>
+              <a:t>65  </a:t>
             </a:r>
             <a:r>
               <a:rPr sz="1250" b="0" i="0">
@@ -6170,7 +6160,7 @@
                 </a:solidFill>
                 <a:latin typeface="Segoe UI"/>
               </a:rPr>
-              <a:t>103  </a:t>
+              <a:t>108  </a:t>
             </a:r>
             <a:r>
               <a:rPr sz="1250" b="0" i="0">
@@ -11446,7 +11436,7 @@
                 </a:solidFill>
                 <a:latin typeface="Segoe UI"/>
               </a:rPr>
-              <a:t>64</a:t>
+              <a:t>65</a:t>
             </a:r>
           </a:p>
           <a:p>
@@ -11478,7 +11468,7 @@
                 </a:solidFill>
                 <a:latin typeface="Segoe UI"/>
               </a:rPr>
-              <a:t>cpp 16 · csharp 5 · go 8 · java 10 · javascript 14 · python 11</a:t>
+              <a:t>cpp 16 · csharp 5 · go 8 · java 10 · javascript 14 · python 12</a:t>
             </a:r>
           </a:p>
         </p:txBody>
@@ -11587,7 +11577,7 @@
                 </a:solidFill>
                 <a:latin typeface="Segoe UI"/>
               </a:rPr>
-              <a:t>103</a:t>
+              <a:t>108</a:t>
             </a:r>
           </a:p>
           <a:p>
@@ -11619,7 +11609,7 @@
                 </a:solidFill>
                 <a:latin typeface="Segoe UI"/>
               </a:rPr>
-              <a:t>cpp 4 · csharp 14 · go 19 · java 16 · javascript 14 · php 14 · python 22</a:t>
+              <a:t>cpp 4 · csharp 14 · go 19 · java 16 · javascript 14 · php 14 · python 27</a:t>
             </a:r>
           </a:p>
         </p:txBody>
@@ -11728,7 +11718,7 @@
                 </a:solidFill>
                 <a:latin typeface="Segoe UI"/>
               </a:rPr>
-              <a:t>~366</a:t>
+              <a:t>~365</a:t>
             </a:r>
           </a:p>
           <a:p>
@@ -24295,7 +24285,7 @@
                 </a:solidFill>
                 <a:latin typeface="Segoe UI"/>
               </a:rPr>
-              <a:t>Homework — scan dvcp (Damn Vulnerable C Program)</a:t>
+              <a:t>Homework — scan dvcp</a:t>
             </a:r>
           </a:p>
         </p:txBody>
@@ -24950,90 +24940,6 @@
                 <a:latin typeface="Consolas"/>
               </a:rPr>
               <a:t>--report</a:t>
-            </a:r>
-          </a:p>
-          <a:p>
-            <a:pPr>
-              <a:spcAft>
-                <a:spcPts val="300"/>
-              </a:spcAft>
-            </a:pPr>
-            <a:r>
-              <a:rPr sz="1550" b="0" i="0">
-                <a:solidFill>
-                  <a:srgbClr val="CCD8E6"/>
-                </a:solidFill>
-                <a:latin typeface="Consolas"/>
-              </a:rPr>
-              <a:t> </a:t>
-            </a:r>
-          </a:p>
-          <a:p>
-            <a:pPr>
-              <a:spcAft>
-                <a:spcPts val="300"/>
-              </a:spcAft>
-            </a:pPr>
-            <a:r>
-              <a:rPr sz="1550" b="0" i="1">
-                <a:solidFill>
-                  <a:srgbClr val="6E8BA3"/>
-                </a:solidFill>
-                <a:latin typeface="Consolas"/>
-              </a:rPr>
-              <a:t># stretch (Linux/macOS): fuzz the real library</a:t>
-            </a:r>
-          </a:p>
-          <a:p>
-            <a:pPr>
-              <a:spcAft>
-                <a:spcPts val="300"/>
-              </a:spcAft>
-            </a:pPr>
-            <a:r>
-              <a:rPr sz="1550" b="1" i="0">
-                <a:solidFill>
-                  <a:srgbClr val="4FC9A8"/>
-                </a:solidFill>
-                <a:latin typeface="Consolas"/>
-              </a:rPr>
-              <a:t>python</a:t>
-            </a:r>
-            <a:r>
-              <a:rPr sz="1550" b="0" i="0">
-                <a:solidFill>
-                  <a:srgbClr val="CCD8E6"/>
-                </a:solidFill>
-                <a:latin typeface="Consolas"/>
-              </a:rPr>
-              <a:t> </a:t>
-            </a:r>
-            <a:r>
-              <a:rPr sz="1550" b="0" i="0">
-                <a:solidFill>
-                  <a:srgbClr val="CCD8E6"/>
-                </a:solidFill>
-                <a:latin typeface="Consolas"/>
-              </a:rPr>
-              <a:t>examples/pipeline_c.py</a:t>
-            </a:r>
-            <a:r>
-              <a:rPr sz="1550" b="0" i="0">
-                <a:solidFill>
-                  <a:srgbClr val="CCD8E6"/>
-                </a:solidFill>
-                <a:latin typeface="Consolas"/>
-              </a:rPr>
-              <a:t> </a:t>
-            </a:r>
-            <a:r>
-              <a:rPr sz="1550" b="0" i="0">
-                <a:solidFill>
-                  <a:srgbClr val="F59E0B"/>
-                </a:solidFill>
-                <a:latin typeface="Consolas"/>
-              </a:rPr>
-              <a:t>--fuzz</a:t>
             </a:r>
           </a:p>
         </p:txBody>
@@ -31490,7 +31396,7 @@
                 </a:solidFill>
                 <a:latin typeface="Segoe UI"/>
               </a:rPr>
-              <a:t>Fuzzing (C/C++)</a:t>
+              <a:t>Guided questions</a:t>
             </a:r>
           </a:p>
           <a:p>
@@ -31506,7 +31412,7 @@
                 </a:solidFill>
                 <a:latin typeface="Segoe UI"/>
               </a:rPr>
-              <a:t>libFuzzer / Atheris / Jazzer + crash triage</a:t>
+              <a:t>Rule-specific checklists grounded in source evidence</a:t>
             </a:r>
           </a:p>
         </p:txBody>
@@ -31615,7 +31521,7 @@
                 </a:solidFill>
                 <a:latin typeface="Segoe UI"/>
               </a:rPr>
-              <a:t>The pipeline — 5 steps, 1 command</a:t>
+              <a:t>The pipeline — 4 stages, 1 command</a:t>
             </a:r>
           </a:p>
         </p:txBody>
@@ -33040,66 +32946,14 @@
       </p:sp>
       <p:sp>
         <p:nvSpPr>
-          <p:cNvPr id="31" name="Rounded Rectangle 30"/>
-          <p:cNvSpPr/>
-          <p:nvPr/>
-        </p:nvSpPr>
-        <p:spPr>
-          <a:xfrm>
-            <a:off x="502920" y="5074920"/>
-            <a:ext cx="11155680" cy="1051560"/>
-          </a:xfrm>
-          <a:prstGeom prst="roundRect">
-            <a:avLst/>
-          </a:prstGeom>
-          <a:solidFill>
-            <a:srgbClr val="EEF2F7"/>
-          </a:solidFill>
-          <a:ln w="12700">
-            <a:solidFill>
-              <a:srgbClr val="DDE4EC"/>
-            </a:solidFill>
-          </a:ln>
-          <a:effectLst>
-            <a:outerShdw blurRad="80000" dist="38000" dir="5400000" rotWithShape="0">
-              <a:srgbClr val="0F172A">
-                <a:alpha val="22000"/>
-              </a:srgbClr>
-            </a:outerShdw>
-          </a:effectLst>
-        </p:spPr>
-        <p:style>
-          <a:lnRef idx="1">
-            <a:schemeClr val="accent1"/>
-          </a:lnRef>
-          <a:fillRef idx="3">
-            <a:schemeClr val="accent1"/>
-          </a:fillRef>
-          <a:effectRef idx="2">
-            <a:schemeClr val="accent1"/>
-          </a:effectRef>
-          <a:fontRef idx="minor">
-            <a:schemeClr val="lt1"/>
-          </a:fontRef>
-        </p:style>
-        <p:txBody>
-          <a:bodyPr rtlCol="0" anchor="ctr"/>
-          <a:lstStyle/>
-          <a:p>
-            <a:pPr algn="ctr"/>
-          </a:p>
-        </p:txBody>
-      </p:sp>
-      <p:sp>
-        <p:nvSpPr>
-          <p:cNvPr id="32" name="TextBox 31"/>
+          <p:cNvPr id="31" name="TextBox 30"/>
           <p:cNvSpPr txBox="1"/>
           <p:nvPr/>
         </p:nvSpPr>
         <p:spPr>
           <a:xfrm>
-            <a:off x="731520" y="5175504"/>
-            <a:ext cx="10607040" cy="365760"/>
+            <a:off x="731520" y="5074920"/>
+            <a:ext cx="10607040" cy="640080"/>
           </a:xfrm>
           <a:prstGeom prst="rect">
             <a:avLst/>
@@ -33112,364 +32966,19 @@
           </a:bodyPr>
           <a:lstStyle/>
           <a:p>
-            <a:pPr algn="l">
+            <a:pPr algn="ctr">
               <a:spcAft>
                 <a:spcPts val="200"/>
               </a:spcAft>
             </a:pPr>
             <a:r>
-              <a:rPr sz="1300" b="1" i="0">
-                <a:solidFill>
-                  <a:srgbClr val="525F70"/>
-                </a:solidFill>
-                <a:latin typeface="Segoe UI"/>
-              </a:rPr>
-              <a:t>+ 4 optional fuzz stages  (C/C++ only)</a:t>
-            </a:r>
-          </a:p>
-        </p:txBody>
-      </p:sp>
-      <p:sp>
-        <p:nvSpPr>
-          <p:cNvPr id="33" name="Rounded Rectangle 32"/>
-          <p:cNvSpPr/>
-          <p:nvPr/>
-        </p:nvSpPr>
-        <p:spPr>
-          <a:xfrm>
-            <a:off x="777240" y="5559552"/>
-            <a:ext cx="2377440" cy="420624"/>
-          </a:xfrm>
-          <a:prstGeom prst="roundRect">
-            <a:avLst/>
-          </a:prstGeom>
-          <a:solidFill>
-            <a:srgbClr val="F59E0B"/>
-          </a:solidFill>
-          <a:ln>
-            <a:noFill/>
-          </a:ln>
-          <a:effectLst/>
-        </p:spPr>
-        <p:style>
-          <a:lnRef idx="1">
-            <a:schemeClr val="accent1"/>
-          </a:lnRef>
-          <a:fillRef idx="3">
-            <a:schemeClr val="accent1"/>
-          </a:fillRef>
-          <a:effectRef idx="2">
-            <a:schemeClr val="accent1"/>
-          </a:effectRef>
-          <a:fontRef idx="minor">
-            <a:schemeClr val="lt1"/>
-          </a:fontRef>
-        </p:style>
-        <p:txBody>
-          <a:bodyPr rtlCol="0" anchor="ctr" wrap="square"/>
-          <a:lstStyle/>
-          <a:p>
-            <a:pPr algn="ctr">
-              <a:spcAft>
-                <a:spcPts val="200"/>
-              </a:spcAft>
-            </a:pPr>
-            <a:r>
-              <a:rPr sz="1150" b="1" i="0">
-                <a:solidFill>
-                  <a:srgbClr val="FFFFFF"/>
-                </a:solidFill>
-                <a:latin typeface="Segoe UI"/>
-              </a:rPr>
-              <a:t>build-sanitized</a:t>
-            </a:r>
-          </a:p>
-        </p:txBody>
-      </p:sp>
-      <p:sp>
-        <p:nvSpPr>
-          <p:cNvPr id="34" name="TextBox 33"/>
-          <p:cNvSpPr txBox="1"/>
-          <p:nvPr/>
-        </p:nvSpPr>
-        <p:spPr>
-          <a:xfrm>
-            <a:off x="3172968" y="5596128"/>
-            <a:ext cx="274320" cy="365760"/>
-          </a:xfrm>
-          <a:prstGeom prst="rect">
-            <a:avLst/>
-          </a:prstGeom>
-          <a:noFill/>
-        </p:spPr>
-        <p:txBody>
-          <a:bodyPr wrap="square" anchor="t" lIns="0" rIns="0" tIns="0" bIns="0">
-            <a:spAutoFit/>
-          </a:bodyPr>
-          <a:lstStyle/>
-          <a:p>
-            <a:pPr algn="ctr">
-              <a:spcAft>
-                <a:spcPts val="200"/>
-              </a:spcAft>
-            </a:pPr>
-            <a:r>
-              <a:rPr sz="1600" b="1" i="0">
-                <a:solidFill>
-                  <a:srgbClr val="F59E0B"/>
-                </a:solidFill>
-                <a:latin typeface="Segoe UI"/>
-              </a:rPr>
-              <a:t>→</a:t>
-            </a:r>
-          </a:p>
-        </p:txBody>
-      </p:sp>
-      <p:sp>
-        <p:nvSpPr>
-          <p:cNvPr id="35" name="Rounded Rectangle 34"/>
-          <p:cNvSpPr/>
-          <p:nvPr/>
-        </p:nvSpPr>
-        <p:spPr>
-          <a:xfrm>
-            <a:off x="3447288" y="5559552"/>
-            <a:ext cx="2377440" cy="420624"/>
-          </a:xfrm>
-          <a:prstGeom prst="roundRect">
-            <a:avLst/>
-          </a:prstGeom>
-          <a:solidFill>
-            <a:srgbClr val="F59E0B"/>
-          </a:solidFill>
-          <a:ln>
-            <a:noFill/>
-          </a:ln>
-          <a:effectLst/>
-        </p:spPr>
-        <p:style>
-          <a:lnRef idx="1">
-            <a:schemeClr val="accent1"/>
-          </a:lnRef>
-          <a:fillRef idx="3">
-            <a:schemeClr val="accent1"/>
-          </a:fillRef>
-          <a:effectRef idx="2">
-            <a:schemeClr val="accent1"/>
-          </a:effectRef>
-          <a:fontRef idx="minor">
-            <a:schemeClr val="lt1"/>
-          </a:fontRef>
-        </p:style>
-        <p:txBody>
-          <a:bodyPr rtlCol="0" anchor="ctr" wrap="square"/>
-          <a:lstStyle/>
-          <a:p>
-            <a:pPr algn="ctr">
-              <a:spcAft>
-                <a:spcPts val="200"/>
-              </a:spcAft>
-            </a:pPr>
-            <a:r>
-              <a:rPr sz="1150" b="1" i="0">
-                <a:solidFill>
-                  <a:srgbClr val="FFFFFF"/>
-                </a:solidFill>
-                <a:latin typeface="Segoe UI"/>
-              </a:rPr>
-              <a:t>extract-fuzz-context</a:t>
-            </a:r>
-          </a:p>
-        </p:txBody>
-      </p:sp>
-      <p:sp>
-        <p:nvSpPr>
-          <p:cNvPr id="36" name="TextBox 35"/>
-          <p:cNvSpPr txBox="1"/>
-          <p:nvPr/>
-        </p:nvSpPr>
-        <p:spPr>
-          <a:xfrm>
-            <a:off x="5843016" y="5596128"/>
-            <a:ext cx="274320" cy="365760"/>
-          </a:xfrm>
-          <a:prstGeom prst="rect">
-            <a:avLst/>
-          </a:prstGeom>
-          <a:noFill/>
-        </p:spPr>
-        <p:txBody>
-          <a:bodyPr wrap="square" anchor="t" lIns="0" rIns="0" tIns="0" bIns="0">
-            <a:spAutoFit/>
-          </a:bodyPr>
-          <a:lstStyle/>
-          <a:p>
-            <a:pPr algn="ctr">
-              <a:spcAft>
-                <a:spcPts val="200"/>
-              </a:spcAft>
-            </a:pPr>
-            <a:r>
-              <a:rPr sz="1600" b="1" i="0">
-                <a:solidFill>
-                  <a:srgbClr val="F59E0B"/>
-                </a:solidFill>
-                <a:latin typeface="Segoe UI"/>
-              </a:rPr>
-              <a:t>→</a:t>
-            </a:r>
-          </a:p>
-        </p:txBody>
-      </p:sp>
-      <p:sp>
-        <p:nvSpPr>
-          <p:cNvPr id="37" name="Rounded Rectangle 36"/>
-          <p:cNvSpPr/>
-          <p:nvPr/>
-        </p:nvSpPr>
-        <p:spPr>
-          <a:xfrm>
-            <a:off x="6117336" y="5559552"/>
-            <a:ext cx="2377440" cy="420624"/>
-          </a:xfrm>
-          <a:prstGeom prst="roundRect">
-            <a:avLst/>
-          </a:prstGeom>
-          <a:solidFill>
-            <a:srgbClr val="F59E0B"/>
-          </a:solidFill>
-          <a:ln>
-            <a:noFill/>
-          </a:ln>
-          <a:effectLst/>
-        </p:spPr>
-        <p:style>
-          <a:lnRef idx="1">
-            <a:schemeClr val="accent1"/>
-          </a:lnRef>
-          <a:fillRef idx="3">
-            <a:schemeClr val="accent1"/>
-          </a:fillRef>
-          <a:effectRef idx="2">
-            <a:schemeClr val="accent1"/>
-          </a:effectRef>
-          <a:fontRef idx="minor">
-            <a:schemeClr val="lt1"/>
-          </a:fontRef>
-        </p:style>
-        <p:txBody>
-          <a:bodyPr rtlCol="0" anchor="ctr" wrap="square"/>
-          <a:lstStyle/>
-          <a:p>
-            <a:pPr algn="ctr">
-              <a:spcAft>
-                <a:spcPts val="200"/>
-              </a:spcAft>
-            </a:pPr>
-            <a:r>
-              <a:rPr sz="1150" b="1" i="0">
-                <a:solidFill>
-                  <a:srgbClr val="FFFFFF"/>
-                </a:solidFill>
-                <a:latin typeface="Segoe UI"/>
-              </a:rPr>
-              <a:t>generate-fuzz-drivers</a:t>
-            </a:r>
-          </a:p>
-        </p:txBody>
-      </p:sp>
-      <p:sp>
-        <p:nvSpPr>
-          <p:cNvPr id="38" name="TextBox 37"/>
-          <p:cNvSpPr txBox="1"/>
-          <p:nvPr/>
-        </p:nvSpPr>
-        <p:spPr>
-          <a:xfrm>
-            <a:off x="8513064" y="5596128"/>
-            <a:ext cx="274320" cy="365760"/>
-          </a:xfrm>
-          <a:prstGeom prst="rect">
-            <a:avLst/>
-          </a:prstGeom>
-          <a:noFill/>
-        </p:spPr>
-        <p:txBody>
-          <a:bodyPr wrap="square" anchor="t" lIns="0" rIns="0" tIns="0" bIns="0">
-            <a:spAutoFit/>
-          </a:bodyPr>
-          <a:lstStyle/>
-          <a:p>
-            <a:pPr algn="ctr">
-              <a:spcAft>
-                <a:spcPts val="200"/>
-              </a:spcAft>
-            </a:pPr>
-            <a:r>
-              <a:rPr sz="1600" b="1" i="0">
-                <a:solidFill>
-                  <a:srgbClr val="F59E0B"/>
-                </a:solidFill>
-                <a:latin typeface="Segoe UI"/>
-              </a:rPr>
-              <a:t>→</a:t>
-            </a:r>
-          </a:p>
-        </p:txBody>
-      </p:sp>
-      <p:sp>
-        <p:nvSpPr>
-          <p:cNvPr id="39" name="Rounded Rectangle 38"/>
-          <p:cNvSpPr/>
-          <p:nvPr/>
-        </p:nvSpPr>
-        <p:spPr>
-          <a:xfrm>
-            <a:off x="8787384" y="5559552"/>
-            <a:ext cx="2377440" cy="420624"/>
-          </a:xfrm>
-          <a:prstGeom prst="roundRect">
-            <a:avLst/>
-          </a:prstGeom>
-          <a:solidFill>
-            <a:srgbClr val="F59E0B"/>
-          </a:solidFill>
-          <a:ln>
-            <a:noFill/>
-          </a:ln>
-          <a:effectLst/>
-        </p:spPr>
-        <p:style>
-          <a:lnRef idx="1">
-            <a:schemeClr val="accent1"/>
-          </a:lnRef>
-          <a:fillRef idx="3">
-            <a:schemeClr val="accent1"/>
-          </a:fillRef>
-          <a:effectRef idx="2">
-            <a:schemeClr val="accent1"/>
-          </a:effectRef>
-          <a:fontRef idx="minor">
-            <a:schemeClr val="lt1"/>
-          </a:fontRef>
-        </p:style>
-        <p:txBody>
-          <a:bodyPr rtlCol="0" anchor="ctr" wrap="square"/>
-          <a:lstStyle/>
-          <a:p>
-            <a:pPr algn="ctr">
-              <a:spcAft>
-                <a:spcPts val="200"/>
-              </a:spcAft>
-            </a:pPr>
-            <a:r>
-              <a:rPr sz="1150" b="1" i="0">
-                <a:solidFill>
-                  <a:srgbClr val="FFFFFF"/>
-                </a:solidFill>
-                <a:latin typeface="Segoe UI"/>
-              </a:rPr>
-              <a:t>fuzz-run</a:t>
+              <a:rPr sz="1800" b="1" i="0">
+                <a:solidFill>
+                  <a:srgbClr val="102A4A"/>
+                </a:solidFill>
+                <a:latin typeface="Segoe UI"/>
+              </a:rPr>
+              <a:t>scan runs prepare → analyze → verify → report</a:t>
             </a:r>
           </a:p>
         </p:txBody>

</xml_diff>